<commit_message>
Update the message key slides
</commit_message>
<xml_diff>
--- a/126/NMOP/draft-ietf-nmop-yang-message-broker-message-key-02.pptx
+++ b/126/NMOP/draft-ietf-nmop-yang-message-broker-message-key-02.pptx
@@ -6940,6 +6940,17 @@
               <a:buNone/>
             </a:pPr>
             <a:r>
+              <a:rPr lang="en-US" sz="1800" b="1" dirty="0"/>
+              <a:t>Status</a:t>
+            </a:r>
+          </a:p>
+          <a:p>
+            <a:pPr>
+              <a:spcBef>
+                <a:spcPts val="600"/>
+              </a:spcBef>
+            </a:pPr>
+            <a:r>
               <a:rPr lang="en-US" sz="1800" b="1" dirty="0">
                 <a:solidFill>
                   <a:srgbClr val="FF0000"/>
@@ -6953,11 +6964,10 @@
             </a:r>
           </a:p>
           <a:p>
-            <a:pPr marL="0" indent="0">
+            <a:pPr>
               <a:spcBef>
                 <a:spcPts val="600"/>
               </a:spcBef>
-              <a:buNone/>
             </a:pPr>
             <a:r>
               <a:rPr lang="en-US" sz="1800" b="1" dirty="0">
@@ -6984,6 +6994,26 @@
                 <a:spcPts val="600"/>
               </a:spcBef>
               <a:buNone/>
+            </a:pPr>
+            <a:endParaRPr lang="en-US" sz="1800" dirty="0"/>
+          </a:p>
+          <a:p>
+            <a:pPr marL="0" indent="0">
+              <a:spcBef>
+                <a:spcPts val="600"/>
+              </a:spcBef>
+              <a:buNone/>
+            </a:pPr>
+            <a:r>
+              <a:rPr lang="en-US" sz="1800" b="1" dirty="0"/>
+              <a:t>Next Steps</a:t>
+            </a:r>
+          </a:p>
+          <a:p>
+            <a:pPr>
+              <a:spcBef>
+                <a:spcPts val="600"/>
+              </a:spcBef>
             </a:pPr>
             <a:r>
               <a:rPr lang="en-US" sz="1800" b="1" dirty="0">

</xml_diff>